<commit_message>
fix: fully translate English PPT (longest-first replacement)
</commit_message>
<xml_diff>
--- a/BEMS_Presentation_EN.pptx
+++ b/BEMS_Presentation_EN.pptx
@@ -3722,7 +3722,7 @@
                 <a:ea typeface="Segoe UI" pitchFamily="34" charset="-122"/>
                 <a:cs typeface="Segoe UI" pitchFamily="34" charset="-120"/>
               </a:rPr>
-              <a:t>Severity · zone 필터 · Diagnose/권고/증거 컬럼 · CSV 내보내기</a:t>
+              <a:t>Severity · zone filters · diagnosis/action/evidence columns · CSV export</a:t>
             </a:r>
             <a:endParaRPr lang="en-US" sz="1100" dirty="0"/>
           </a:p>
@@ -10978,7 +10978,7 @@
                 <a:ea typeface="Segoe UI" pitchFamily="34" charset="-122"/>
                 <a:cs typeface="Segoe UI" pitchFamily="34" charset="-120"/>
               </a:rPr>
-              <a:t>What You Can Do With It</a:t>
+              <a:t>What the system can do</a:t>
             </a:r>
             <a:endParaRPr lang="en-US" sz="3000" dirty="0"/>
           </a:p>
@@ -11351,7 +11351,7 @@
                 <a:ea typeface="Segoe UI" pitchFamily="34" charset="-122"/>
                 <a:cs typeface="Segoe UI" pitchFamily="34" charset="-120"/>
               </a:rPr>
-              <a:t>Packet Loss Recover</a:t>
+              <a:t>Packet-loss recovery</a:t>
             </a:r>
             <a:endParaRPr lang="en-US" sz="1300" dirty="0"/>
           </a:p>
@@ -11525,7 +11525,7 @@
                 <a:ea typeface="Segoe UI" pitchFamily="34" charset="-122"/>
                 <a:cs typeface="Segoe UI" pitchFamily="34" charset="-120"/>
               </a:rPr>
-              <a:t>다중 Detect기 비교</a:t>
+              <a:t>Multi-detector comparison</a:t>
             </a:r>
             <a:endParaRPr lang="en-US" sz="1300" dirty="0"/>
           </a:p>
@@ -11738,7 +11738,7 @@
                 <a:ea typeface="Segoe UI" pitchFamily="34" charset="-122"/>
                 <a:cs typeface="Segoe UI" pitchFamily="34" charset="-120"/>
               </a:rPr>
-              <a:t>9개 룰을 매칭하여 어떤 유형의 사고인지 Diagnose + 권고 조치 출력</a:t>
+              <a:t>Match 9 rules to diagnose the event type and output a recommended action</a:t>
             </a:r>
             <a:endParaRPr lang="en-US" sz="1050" dirty="0"/>
           </a:p>
@@ -11873,7 +11873,7 @@
                 <a:ea typeface="Segoe UI" pitchFamily="34" charset="-122"/>
                 <a:cs typeface="Segoe UI" pitchFamily="34" charset="-120"/>
               </a:rPr>
-              <a:t>시나리오 주입 Testing</a:t>
+              <a:t>Scenario injection testing</a:t>
             </a:r>
             <a:endParaRPr lang="en-US" sz="1300" dirty="0"/>
           </a:p>
@@ -12260,7 +12260,7 @@
                 <a:ea typeface="Segoe UI" pitchFamily="34" charset="-122"/>
                 <a:cs typeface="Segoe UI" pitchFamily="34" charset="-120"/>
               </a:rPr>
-              <a:t>필터링한 알림 목록을 CSV로 다운로드 (Operate 보고서 생성)</a:t>
+              <a:t>Download the filtered alert list as CSV (operations report)</a:t>
             </a:r>
             <a:endParaRPr lang="en-US" sz="1050" dirty="0"/>
           </a:p>
@@ -12395,7 +12395,7 @@
                 <a:ea typeface="Segoe UI" pitchFamily="34" charset="-122"/>
                 <a:cs typeface="Segoe UI" pitchFamily="34" charset="-120"/>
               </a:rPr>
-              <a:t>데이터 Persistence 및 리셋</a:t>
+              <a:t>Data persistence &amp; reset</a:t>
             </a:r>
             <a:endParaRPr lang="en-US" sz="1300" dirty="0"/>
           </a:p>
@@ -12853,7 +12853,7 @@
                 <a:ea typeface="Segoe UI" pitchFamily="34" charset="-122"/>
                 <a:cs typeface="Segoe UI" pitchFamily="34" charset="-120"/>
               </a:rPr>
-              <a:t>Six-Stage Agent Pipeline — 모두 독립 프로세스로 분리</a:t>
+              <a:t>Six-stage agent pipeline — every stage an independent process</a:t>
             </a:r>
             <a:endParaRPr lang="en-US" sz="1100" dirty="0"/>
           </a:p>
@@ -12931,7 +12931,7 @@
                 <a:ea typeface="Segoe UI" pitchFamily="34" charset="-122"/>
                 <a:cs typeface="Segoe UI" pitchFamily="34" charset="-120"/>
               </a:rPr>
-              <a:t>10% Packet Loss + 0.2–1.5s 지연 환경에서 시계열 무결성 유지</a:t>
+              <a:t>Keeps the series intact under 10% packet loss + 0.2–1.5 s delay</a:t>
             </a:r>
             <a:endParaRPr lang="en-US" sz="1100" dirty="0"/>
           </a:p>
@@ -13087,7 +13087,7 @@
                 <a:ea typeface="Segoe UI" pitchFamily="34" charset="-122"/>
                 <a:cs typeface="Segoe UI" pitchFamily="34" charset="-120"/>
               </a:rPr>
-              <a:t>9개 룰 엔진으로 결정론적·감사 가능한 Diagnose (블랙박스 X)</a:t>
+              <a:t>9-rule engine — deterministic, auditable diagnosis (no black box)</a:t>
             </a:r>
             <a:endParaRPr lang="en-US" sz="1100" dirty="0"/>
           </a:p>
@@ -13165,7 +13165,7 @@
                 <a:ea typeface="Segoe UI" pitchFamily="34" charset="-122"/>
                 <a:cs typeface="Segoe UI" pitchFamily="34" charset="-120"/>
               </a:rPr>
-              <a:t>엔터프라이즈 톤의 6탭 Operate 콘솔</a:t>
+              <a:t>Enterprise-style 6-tab operations console</a:t>
             </a:r>
             <a:endParaRPr lang="en-US" sz="1100" dirty="0"/>
           </a:p>
@@ -13243,7 +13243,7 @@
                 <a:ea typeface="Segoe UI" pitchFamily="34" charset="-122"/>
                 <a:cs typeface="Segoe UI" pitchFamily="34" charset="-120"/>
               </a:rPr>
-              <a:t>Pytest 24개 — 데드락 회귀 Testing 포함</a:t>
+              <a:t>24 pytest cases — including a deadlock regression test</a:t>
             </a:r>
             <a:endParaRPr lang="en-US" sz="1100" dirty="0"/>
           </a:p>
@@ -15789,7 +15789,7 @@
                 <a:ea typeface="Segoe UI" pitchFamily="34" charset="-122"/>
                 <a:cs typeface="Segoe UI" pitchFamily="34" charset="-120"/>
               </a:rPr>
-              <a:t>What You Can Do With It</a:t>
+              <a:t>What the system can do</a:t>
             </a:r>
             <a:endParaRPr lang="en-US" sz="1000" dirty="0"/>
           </a:p>
@@ -16971,7 +16971,7 @@
                 <a:ea typeface="Segoe UI" pitchFamily="34" charset="-122"/>
                 <a:cs typeface="Segoe UI" pitchFamily="34" charset="-120"/>
               </a:rPr>
-              <a:t>Six-Stage Agent Pipeline — 실제 Network degradation를 의도적으로 주입하고, ML로 Recover하고, 룰 엔진으로 Diagnose합니다.</a:t>
+              <a:t>A six-stage agent pipeline — deliberately inject network degradation, recover with ML, diagnose with a rule engine.</a:t>
             </a:r>
             <a:endParaRPr lang="en-US" sz="1200" dirty="0"/>
           </a:p>
@@ -17439,7 +17439,7 @@
                 <a:ea typeface="Segoe UI" pitchFamily="34" charset="-122"/>
                 <a:cs typeface="Segoe UI" pitchFamily="34" charset="-120"/>
               </a:rPr>
-              <a:t>Streamlit 콘솔 — 6탭 Operate 화면과 시나리오 주입 기능</a:t>
+              <a:t>Streamlit console — 6-tab operations view with scenario injection</a:t>
             </a:r>
             <a:endParaRPr lang="en-US" sz="1000" dirty="0"/>
           </a:p>
@@ -18487,7 +18487,7 @@
                 <a:ea typeface="Segoe UI" pitchFamily="34" charset="-122"/>
                 <a:cs typeface="Segoe UI" pitchFamily="34" charset="-120"/>
               </a:rPr>
-              <a:t>보간 + 이상 Detect</a:t>
+              <a:t>Interpolate + detect</a:t>
             </a:r>
             <a:endParaRPr lang="en-US" sz="1000" dirty="0"/>
           </a:p>
@@ -18686,7 +18686,7 @@
                 <a:ea typeface="Segoe UI" pitchFamily="34" charset="-122"/>
                 <a:cs typeface="Segoe UI" pitchFamily="34" charset="-120"/>
               </a:rPr>
-              <a:t>룰 엔진 Diagnose</a:t>
+              <a:t>Rule-engine diagnosis</a:t>
             </a:r>
             <a:endParaRPr lang="en-US" sz="1000" dirty="0"/>
           </a:p>
@@ -18885,7 +18885,7 @@
                 <a:ea typeface="Segoe UI" pitchFamily="34" charset="-122"/>
                 <a:cs typeface="Segoe UI" pitchFamily="34" charset="-120"/>
               </a:rPr>
-              <a:t>Operate 콘솔</a:t>
+              <a:t>Operations console</a:t>
             </a:r>
             <a:endParaRPr lang="en-US" sz="1000" dirty="0"/>
           </a:p>
@@ -24597,7 +24597,7 @@
                 <a:ea typeface="Segoe UI" pitchFamily="34" charset="-122"/>
                 <a:cs typeface="Segoe UI" pitchFamily="34" charset="-120"/>
               </a:rPr>
-              <a:t>Operate 저장소 초기화</a:t>
+              <a:t>Reset the operational store</a:t>
             </a:r>
             <a:endParaRPr lang="en-US" sz="1000" dirty="0"/>
           </a:p>
@@ -24881,7 +24881,7 @@
                 <a:ea typeface="Segoe UI" pitchFamily="34" charset="-122"/>
                 <a:cs typeface="Segoe UI" pitchFamily="34" charset="-120"/>
               </a:rPr>
-              <a:t>ML Recover + 이상 플래그 프레임</a:t>
+              <a:t>ML-recovered + anomaly-flagged frame</a:t>
             </a:r>
             <a:endParaRPr lang="en-US" sz="1000" dirty="0"/>
           </a:p>
@@ -25307,7 +25307,7 @@
                 <a:ea typeface="Segoe UI" pitchFamily="34" charset="-122"/>
                 <a:cs typeface="Segoe UI" pitchFamily="34" charset="-120"/>
               </a:rPr>
-              <a:t>보간 MAE + Detect P/R/F1</a:t>
+              <a:t>Interpolation MAE + detection P/R/F1</a:t>
             </a:r>
             <a:endParaRPr lang="en-US" sz="1000" dirty="0"/>
           </a:p>

</xml_diff>